<commit_message>
Add NLP projects slide to the internship deck
Third slide covering the two hands-on NLP projects: word-type
classification with spaCy Named Entity Recognition, and review sentiment
with TF-IDF vectors, three supervised classifiers and a word cloud.

Co-Authored-By: Claude Fable 5.1 <noreply@anthropic.com>
Claude-Session: https://claude.ai/code/session_013C7PUHkdKFR5RJx432vMai
</commit_message>
<xml_diff>
--- a/slides/cars_classification_slides.pptx
+++ b/slides/cars_classification_slides.pptx
@@ -7,6 +7,7 @@
   <p:sldIdLst>
     <p:sldId id="256" r:id="rId12"/>
     <p:sldId id="257" r:id="rId13"/>
+    <p:sldId id="258" r:id="rId11"/>
   </p:sldIdLst>
   <p:sldSz cx="18288000" cy="10287000"/>
   <p:notesSz cx="6858000" cy="9144000"/>
@@ -11771,6 +11772,1333 @@
 </p:sld>
 </file>
 
+<file path=ppt/slides/slide3.xml><?xml version="1.0" encoding="utf-8"?>
+<p:sld xmlns:a="http://schemas.openxmlformats.org/drawingml/2006/main" xmlns:p="http://schemas.openxmlformats.org/presentationml/2006/main" xmlns:r="http://schemas.openxmlformats.org/officeDocument/2006/relationships">
+  <p:cSld>
+    <p:spTree>
+      <p:nvGrpSpPr>
+        <p:cNvPr id="1" name=""/>
+        <p:cNvGrpSpPr/>
+        <p:nvPr/>
+      </p:nvGrpSpPr>
+      <p:grpSpPr/>
+      <p:sp>
+        <p:nvSpPr>
+          <p:cNvPr id="2" name="Title"/>
+          <p:cNvSpPr txBox="1"/>
+          <p:nvPr/>
+        </p:nvSpPr>
+        <p:spPr>
+          <a:xfrm>
+            <a:off x="1028700" y="777240"/>
+            <a:ext cx="16230600" cy="960120"/>
+          </a:xfrm>
+          <a:prstGeom prst="rect">
+            <a:avLst/>
+          </a:prstGeom>
+          <a:noFill/>
+        </p:spPr>
+        <p:txBody>
+          <a:bodyPr wrap="square" lIns="0" rIns="0" tIns="0" bIns="0" anchor="t">
+            <a:spAutoFit/>
+          </a:bodyPr>
+          <a:lstStyle/>
+          <a:p>
+            <a:pPr algn="l"/>
+            <a:r>
+              <a:rPr sz="6000" b="0" lang="en-US" spc="-300">
+                <a:solidFill>
+                  <a:srgbClr val="000000"/>
+                </a:solidFill>
+                <a:latin typeface="Helios Extended"/>
+              </a:rPr>
+              <a:t>Natural Language Processing</a:t>
+            </a:r>
+          </a:p>
+        </p:txBody>
+      </p:sp>
+      <p:sp>
+        <p:nvSpPr>
+          <p:cNvPr id="3" name="Subtitle"/>
+          <p:cNvSpPr txBox="1"/>
+          <p:nvPr/>
+        </p:nvSpPr>
+        <p:spPr>
+          <a:xfrm>
+            <a:off x="1028700" y="1828800"/>
+            <a:ext cx="16230600" cy="457200"/>
+          </a:xfrm>
+          <a:prstGeom prst="rect">
+            <a:avLst/>
+          </a:prstGeom>
+          <a:noFill/>
+        </p:spPr>
+        <p:txBody>
+          <a:bodyPr wrap="square" lIns="0" rIns="0" tIns="0" bIns="0" anchor="t">
+            <a:spAutoFit/>
+          </a:bodyPr>
+          <a:lstStyle/>
+          <a:p>
+            <a:pPr algn="l"/>
+            <a:r>
+              <a:rPr sz="2400" b="0" lang="en-US">
+                <a:solidFill>
+                  <a:srgbClr val="555555"/>
+                </a:solidFill>
+                <a:latin typeface="Helvetica World"/>
+              </a:rPr>
+              <a:t>Hands-on coding: word types &amp; NER with spaCy, and review sentiment with TF-IDF + classic ML</a:t>
+            </a:r>
+          </a:p>
+        </p:txBody>
+      </p:sp>
+      <p:sp>
+        <p:nvSpPr>
+          <p:cNvPr id="4" name="Footer left"/>
+          <p:cNvSpPr txBox="1"/>
+          <p:nvPr/>
+        </p:nvSpPr>
+        <p:spPr>
+          <a:xfrm>
+            <a:off x="1028700" y="9345168"/>
+            <a:ext cx="7315200" cy="274320"/>
+          </a:xfrm>
+          <a:prstGeom prst="rect">
+            <a:avLst/>
+          </a:prstGeom>
+          <a:noFill/>
+        </p:spPr>
+        <p:txBody>
+          <a:bodyPr wrap="square" lIns="0" rIns="0" tIns="0" bIns="0" anchor="t">
+            <a:spAutoFit/>
+          </a:bodyPr>
+          <a:lstStyle/>
+          <a:p>
+            <a:pPr algn="l"/>
+            <a:r>
+              <a:rPr sz="1600" b="0" lang="en-US" spc="279">
+                <a:solidFill>
+                  <a:srgbClr val="000000"/>
+                </a:solidFill>
+                <a:latin typeface="Helvetica World"/>
+              </a:rPr>
+              <a:t>NLP PROJECTS</a:t>
+            </a:r>
+          </a:p>
+        </p:txBody>
+      </p:sp>
+      <p:sp>
+        <p:nvSpPr>
+          <p:cNvPr id="5" name="Footer right"/>
+          <p:cNvSpPr txBox="1"/>
+          <p:nvPr/>
+        </p:nvSpPr>
+        <p:spPr>
+          <a:xfrm>
+            <a:off x="9944100" y="9345168"/>
+            <a:ext cx="7315200" cy="274320"/>
+          </a:xfrm>
+          <a:prstGeom prst="rect">
+            <a:avLst/>
+          </a:prstGeom>
+          <a:noFill/>
+        </p:spPr>
+        <p:txBody>
+          <a:bodyPr wrap="square" lIns="0" rIns="0" tIns="0" bIns="0" anchor="t">
+            <a:spAutoFit/>
+          </a:bodyPr>
+          <a:lstStyle/>
+          <a:p>
+            <a:pPr algn="r"/>
+            <a:r>
+              <a:rPr sz="1600" b="0" lang="en-US" spc="279">
+                <a:solidFill>
+                  <a:srgbClr val="000000"/>
+                </a:solidFill>
+                <a:latin typeface="Helvetica World"/>
+              </a:rPr>
+              <a:t>MISA INTERNSHIP</a:t>
+            </a:r>
+          </a:p>
+        </p:txBody>
+      </p:sp>
+      <p:sp>
+        <p:nvSpPr>
+          <p:cNvPr id="6" name="Footer bar"/>
+          <p:cNvSpPr/>
+          <p:nvPr/>
+        </p:nvSpPr>
+        <p:spPr>
+          <a:xfrm>
+            <a:off x="0" y="9925812"/>
+            <a:ext cx="18288000" cy="361188"/>
+          </a:xfrm>
+          <a:prstGeom prst="rect">
+            <a:avLst/>
+          </a:prstGeom>
+          <a:solidFill>
+            <a:srgbClr val="D40011"/>
+          </a:solidFill>
+          <a:ln>
+            <a:noFill/>
+          </a:ln>
+        </p:spPr>
+        <p:txBody>
+          <a:bodyPr rtlCol="0" anchor="ctr"/>
+          <a:lstStyle/>
+          <a:p>
+            <a:pPr algn="ctr"/>
+          </a:p>
+        </p:txBody>
+      </p:sp>
+      <p:sp>
+        <p:nvSpPr>
+          <p:cNvPr id="7" name="Card 1"/>
+          <p:cNvSpPr/>
+          <p:nvPr/>
+        </p:nvSpPr>
+        <p:spPr>
+          <a:xfrm>
+            <a:off x="914400" y="2606040"/>
+            <a:ext cx="7955279" cy="6309360"/>
+          </a:xfrm>
+          <a:prstGeom prst="rect">
+            <a:avLst/>
+          </a:prstGeom>
+          <a:solidFill>
+            <a:srgbClr val="E1E3DE"/>
+          </a:solidFill>
+          <a:ln>
+            <a:noFill/>
+          </a:ln>
+        </p:spPr>
+        <p:txBody>
+          <a:bodyPr rtlCol="0" anchor="ctr"/>
+          <a:lstStyle/>
+          <a:p>
+            <a:pPr algn="ctr"/>
+          </a:p>
+        </p:txBody>
+      </p:sp>
+      <p:sp>
+        <p:nvSpPr>
+          <p:cNvPr id="8" name="Card 1 badge"/>
+          <p:cNvSpPr/>
+          <p:nvPr/>
+        </p:nvSpPr>
+        <p:spPr>
+          <a:xfrm>
+            <a:off x="1234440" y="2880360"/>
+            <a:ext cx="640080" cy="640080"/>
+          </a:xfrm>
+          <a:prstGeom prst="rect">
+            <a:avLst/>
+          </a:prstGeom>
+          <a:solidFill>
+            <a:srgbClr val="98C4EC"/>
+          </a:solidFill>
+          <a:ln>
+            <a:noFill/>
+          </a:ln>
+        </p:spPr>
+        <p:txBody>
+          <a:bodyPr rtlCol="0" anchor="ctr"/>
+          <a:lstStyle/>
+          <a:p>
+            <a:pPr algn="ctr"/>
+          </a:p>
+        </p:txBody>
+      </p:sp>
+      <p:sp>
+        <p:nvSpPr>
+          <p:cNvPr id="9" name="TextBox 8"/>
+          <p:cNvSpPr txBox="1"/>
+          <p:nvPr/>
+        </p:nvSpPr>
+        <p:spPr>
+          <a:xfrm>
+            <a:off x="1234440" y="2880360"/>
+            <a:ext cx="640080" cy="640080"/>
+          </a:xfrm>
+          <a:prstGeom prst="rect">
+            <a:avLst/>
+          </a:prstGeom>
+          <a:noFill/>
+        </p:spPr>
+        <p:txBody>
+          <a:bodyPr wrap="square" lIns="0" rIns="0" tIns="0" bIns="0" anchor="ctr">
+            <a:spAutoFit/>
+          </a:bodyPr>
+          <a:lstStyle/>
+          <a:p>
+            <a:pPr algn="ctr"/>
+            <a:r>
+              <a:rPr sz="2800" b="0" lang="en-US">
+                <a:solidFill>
+                  <a:srgbClr val="FFFFFF"/>
+                </a:solidFill>
+                <a:latin typeface="Helios Extended"/>
+              </a:rPr>
+              <a:t>01</a:t>
+            </a:r>
+          </a:p>
+        </p:txBody>
+      </p:sp>
+      <p:sp>
+        <p:nvSpPr>
+          <p:cNvPr id="10" name="TextBox 9"/>
+          <p:cNvSpPr txBox="1"/>
+          <p:nvPr/>
+        </p:nvSpPr>
+        <p:spPr>
+          <a:xfrm>
+            <a:off x="2057400" y="2880360"/>
+            <a:ext cx="6492239" cy="640080"/>
+          </a:xfrm>
+          <a:prstGeom prst="rect">
+            <a:avLst/>
+          </a:prstGeom>
+          <a:noFill/>
+        </p:spPr>
+        <p:txBody>
+          <a:bodyPr wrap="square" lIns="0" rIns="0" tIns="0" bIns="0" anchor="ctr">
+            <a:spAutoFit/>
+          </a:bodyPr>
+          <a:lstStyle/>
+          <a:p>
+            <a:pPr algn="l"/>
+            <a:r>
+              <a:rPr sz="2400" b="1" lang="en-US">
+                <a:solidFill>
+                  <a:srgbClr val="000000"/>
+                </a:solidFill>
+                <a:latin typeface="Helvetica World"/>
+              </a:rPr>
+              <a:t>Word types &amp; Named Entity Recognition</a:t>
+            </a:r>
+          </a:p>
+        </p:txBody>
+      </p:sp>
+      <p:sp>
+        <p:nvSpPr>
+          <p:cNvPr id="11" name="TextBox 10"/>
+          <p:cNvSpPr txBox="1"/>
+          <p:nvPr/>
+        </p:nvSpPr>
+        <p:spPr>
+          <a:xfrm>
+            <a:off x="1234440" y="3703320"/>
+            <a:ext cx="7315199" cy="1463040"/>
+          </a:xfrm>
+          <a:prstGeom prst="rect">
+            <a:avLst/>
+          </a:prstGeom>
+          <a:noFill/>
+        </p:spPr>
+        <p:txBody>
+          <a:bodyPr wrap="square" lIns="0" rIns="0" tIns="0" bIns="0" anchor="t">
+            <a:spAutoFit/>
+          </a:bodyPr>
+          <a:lstStyle/>
+          <a:p>
+            <a:pPr algn="l" marL="320040" indent="-320040">
+              <a:spcAft>
+                <a:spcPts val="800"/>
+              </a:spcAft>
+              <a:buFont typeface="Arial"/>
+              <a:buChar char="•"/>
+            </a:pPr>
+            <a:r>
+              <a:rPr sz="2000" b="0" lang="en-US">
+                <a:solidFill>
+                  <a:srgbClr val="000000"/>
+                </a:solidFill>
+                <a:latin typeface="Helvetica World"/>
+              </a:rPr>
+              <a:t>Built and trained a Sequential neural network to classify words into different types</a:t>
+            </a:r>
+          </a:p>
+          <a:p>
+            <a:pPr algn="l" marL="320040" indent="-320040">
+              <a:spcAft>
+                <a:spcPts val="800"/>
+              </a:spcAft>
+              <a:buFont typeface="Arial"/>
+              <a:buChar char="•"/>
+            </a:pPr>
+            <a:r>
+              <a:rPr sz="2000" b="0" lang="en-US">
+                <a:solidFill>
+                  <a:srgbClr val="000000"/>
+                </a:solidFill>
+                <a:latin typeface="Helvetica World"/>
+              </a:rPr>
+              <a:t>Loaded spaCy's pretrained pipeline as a Named Entity Recognizer to show those types in real text</a:t>
+            </a:r>
+          </a:p>
+        </p:txBody>
+      </p:sp>
+      <p:sp>
+        <p:nvSpPr>
+          <p:cNvPr id="12" name="Card 1 code"/>
+          <p:cNvSpPr/>
+          <p:nvPr/>
+        </p:nvSpPr>
+        <p:spPr>
+          <a:xfrm>
+            <a:off x="1234440" y="5257800"/>
+            <a:ext cx="7315199" cy="777240"/>
+          </a:xfrm>
+          <a:prstGeom prst="rect">
+            <a:avLst/>
+          </a:prstGeom>
+          <a:solidFill>
+            <a:srgbClr val="FFFFFF"/>
+          </a:solidFill>
+          <a:ln>
+            <a:noFill/>
+          </a:ln>
+        </p:spPr>
+        <p:txBody>
+          <a:bodyPr rtlCol="0" anchor="ctr"/>
+          <a:lstStyle/>
+          <a:p>
+            <a:pPr algn="ctr"/>
+          </a:p>
+        </p:txBody>
+      </p:sp>
+      <p:sp>
+        <p:nvSpPr>
+          <p:cNvPr id="13" name="TextBox 12"/>
+          <p:cNvSpPr txBox="1"/>
+          <p:nvPr/>
+        </p:nvSpPr>
+        <p:spPr>
+          <a:xfrm>
+            <a:off x="1417320" y="5257800"/>
+            <a:ext cx="6949439" cy="777240"/>
+          </a:xfrm>
+          <a:prstGeom prst="rect">
+            <a:avLst/>
+          </a:prstGeom>
+          <a:noFill/>
+        </p:spPr>
+        <p:txBody>
+          <a:bodyPr wrap="square" lIns="0" rIns="0" tIns="0" bIns="0" anchor="ctr">
+            <a:spAutoFit/>
+          </a:bodyPr>
+          <a:lstStyle/>
+          <a:p>
+            <a:pPr algn="l"/>
+            <a:r>
+              <a:rPr sz="1600" b="0" lang="en-US">
+                <a:solidFill>
+                  <a:srgbClr val="000000"/>
+                </a:solidFill>
+                <a:latin typeface="Courier New"/>
+              </a:rPr>
+              <a:t>nlp = spacy.load('en_core_web_sm')</a:t>
+            </a:r>
+          </a:p>
+          <a:p>
+            <a:pPr algn="l"/>
+            <a:r>
+              <a:rPr sz="1600" b="0" lang="en-US">
+                <a:solidFill>
+                  <a:srgbClr val="000000"/>
+                </a:solidFill>
+                <a:latin typeface="Courier New"/>
+              </a:rPr>
+              <a:t>displacy.render(nlp(text), style='ent')</a:t>
+            </a:r>
+          </a:p>
+        </p:txBody>
+      </p:sp>
+      <p:pic>
+        <p:nvPicPr>
+          <p:cNvPr id="14" name="NER example" descr="ner.png"/>
+          <p:cNvPicPr>
+            <a:picLocks noChangeAspect="1"/>
+          </p:cNvPicPr>
+          <p:nvPr/>
+        </p:nvPicPr>
+        <p:blipFill>
+          <a:blip r:embed="rId2"/>
+          <a:stretch>
+            <a:fillRect/>
+          </a:stretch>
+        </p:blipFill>
+        <p:spPr>
+          <a:xfrm>
+            <a:off x="1234440" y="6217920"/>
+            <a:ext cx="7315199" cy="905043"/>
+          </a:xfrm>
+          <a:prstGeom prst="rect">
+            <a:avLst/>
+          </a:prstGeom>
+        </p:spPr>
+      </p:pic>
+      <p:sp>
+        <p:nvSpPr>
+          <p:cNvPr id="15" name="NER caption"/>
+          <p:cNvSpPr txBox="1"/>
+          <p:nvPr/>
+        </p:nvSpPr>
+        <p:spPr>
+          <a:xfrm>
+            <a:off x="1234440" y="7232691"/>
+            <a:ext cx="7315199" cy="685800"/>
+          </a:xfrm>
+          <a:prstGeom prst="rect">
+            <a:avLst/>
+          </a:prstGeom>
+          <a:noFill/>
+        </p:spPr>
+        <p:txBody>
+          <a:bodyPr wrap="square" lIns="0" rIns="0" tIns="0" bIns="0" anchor="t">
+            <a:spAutoFit/>
+          </a:bodyPr>
+          <a:lstStyle/>
+          <a:p>
+            <a:pPr algn="l"/>
+            <a:r>
+              <a:rPr sz="1600" b="0" lang="en-US">
+                <a:solidFill>
+                  <a:srgbClr val="555555"/>
+                </a:solidFill>
+                <a:latin typeface="Helvetica World"/>
+              </a:rPr>
+              <a:t>displaCy output of en_core_web_sm on a tech-news sentence. The small model still slips: 'Optimizer' is tagged GPE.</a:t>
+            </a:r>
+          </a:p>
+        </p:txBody>
+      </p:sp>
+      <p:sp>
+        <p:nvSpPr>
+          <p:cNvPr id="16" name="Entity PRODUCT"/>
+          <p:cNvSpPr/>
+          <p:nvPr/>
+        </p:nvSpPr>
+        <p:spPr>
+          <a:xfrm>
+            <a:off x="1234440" y="8092440"/>
+            <a:ext cx="1691639" cy="548640"/>
+          </a:xfrm>
+          <a:prstGeom prst="rect">
+            <a:avLst/>
+          </a:prstGeom>
+          <a:solidFill>
+            <a:srgbClr val="BFEEB7"/>
+          </a:solidFill>
+          <a:ln>
+            <a:noFill/>
+          </a:ln>
+        </p:spPr>
+        <p:txBody>
+          <a:bodyPr rtlCol="0" anchor="ctr"/>
+          <a:lstStyle/>
+          <a:p>
+            <a:pPr algn="ctr"/>
+          </a:p>
+        </p:txBody>
+      </p:sp>
+      <p:sp>
+        <p:nvSpPr>
+          <p:cNvPr id="17" name="TextBox 16"/>
+          <p:cNvSpPr txBox="1"/>
+          <p:nvPr/>
+        </p:nvSpPr>
+        <p:spPr>
+          <a:xfrm>
+            <a:off x="1325880" y="8092440"/>
+            <a:ext cx="1508759" cy="548640"/>
+          </a:xfrm>
+          <a:prstGeom prst="rect">
+            <a:avLst/>
+          </a:prstGeom>
+          <a:noFill/>
+        </p:spPr>
+        <p:txBody>
+          <a:bodyPr wrap="square" lIns="0" rIns="0" tIns="0" bIns="0" anchor="ctr">
+            <a:spAutoFit/>
+          </a:bodyPr>
+          <a:lstStyle/>
+          <a:p>
+            <a:pPr algn="ctr"/>
+            <a:r>
+              <a:rPr sz="1500" b="1" lang="en-US">
+                <a:solidFill>
+                  <a:srgbClr val="000000"/>
+                </a:solidFill>
+                <a:latin typeface="Helvetica World"/>
+              </a:rPr>
+              <a:t>PRODUCT</a:t>
+            </a:r>
+          </a:p>
+          <a:p>
+            <a:pPr algn="ctr"/>
+            <a:r>
+              <a:rPr sz="1400" b="0" lang="en-US">
+                <a:solidFill>
+                  <a:srgbClr val="000000"/>
+                </a:solidFill>
+                <a:latin typeface="Helvetica World"/>
+              </a:rPr>
+              <a:t>products, software</a:t>
+            </a:r>
+          </a:p>
+        </p:txBody>
+      </p:sp>
+      <p:sp>
+        <p:nvSpPr>
+          <p:cNvPr id="18" name="Entity ORG"/>
+          <p:cNvSpPr/>
+          <p:nvPr/>
+        </p:nvSpPr>
+        <p:spPr>
+          <a:xfrm>
+            <a:off x="3108960" y="8092440"/>
+            <a:ext cx="1691639" cy="548640"/>
+          </a:xfrm>
+          <a:prstGeom prst="rect">
+            <a:avLst/>
+          </a:prstGeom>
+          <a:solidFill>
+            <a:srgbClr val="7AECEC"/>
+          </a:solidFill>
+          <a:ln>
+            <a:noFill/>
+          </a:ln>
+        </p:spPr>
+        <p:txBody>
+          <a:bodyPr rtlCol="0" anchor="ctr"/>
+          <a:lstStyle/>
+          <a:p>
+            <a:pPr algn="ctr"/>
+          </a:p>
+        </p:txBody>
+      </p:sp>
+      <p:sp>
+        <p:nvSpPr>
+          <p:cNvPr id="19" name="TextBox 18"/>
+          <p:cNvSpPr txBox="1"/>
+          <p:nvPr/>
+        </p:nvSpPr>
+        <p:spPr>
+          <a:xfrm>
+            <a:off x="3200400" y="8092440"/>
+            <a:ext cx="1508759" cy="548640"/>
+          </a:xfrm>
+          <a:prstGeom prst="rect">
+            <a:avLst/>
+          </a:prstGeom>
+          <a:noFill/>
+        </p:spPr>
+        <p:txBody>
+          <a:bodyPr wrap="square" lIns="0" rIns="0" tIns="0" bIns="0" anchor="ctr">
+            <a:spAutoFit/>
+          </a:bodyPr>
+          <a:lstStyle/>
+          <a:p>
+            <a:pPr algn="ctr"/>
+            <a:r>
+              <a:rPr sz="1500" b="1" lang="en-US">
+                <a:solidFill>
+                  <a:srgbClr val="000000"/>
+                </a:solidFill>
+                <a:latin typeface="Helvetica World"/>
+              </a:rPr>
+              <a:t>ORG</a:t>
+            </a:r>
+          </a:p>
+          <a:p>
+            <a:pPr algn="ctr"/>
+            <a:r>
+              <a:rPr sz="1400" b="0" lang="en-US">
+                <a:solidFill>
+                  <a:srgbClr val="000000"/>
+                </a:solidFill>
+                <a:latin typeface="Helvetica World"/>
+              </a:rPr>
+              <a:t>companies, groups</a:t>
+            </a:r>
+          </a:p>
+        </p:txBody>
+      </p:sp>
+      <p:sp>
+        <p:nvSpPr>
+          <p:cNvPr id="20" name="Entity WORK_OF_ART"/>
+          <p:cNvSpPr/>
+          <p:nvPr/>
+        </p:nvSpPr>
+        <p:spPr>
+          <a:xfrm>
+            <a:off x="4983479" y="8092440"/>
+            <a:ext cx="1691639" cy="548640"/>
+          </a:xfrm>
+          <a:prstGeom prst="rect">
+            <a:avLst/>
+          </a:prstGeom>
+          <a:solidFill>
+            <a:srgbClr val="F0D0FF"/>
+          </a:solidFill>
+          <a:ln>
+            <a:noFill/>
+          </a:ln>
+        </p:spPr>
+        <p:txBody>
+          <a:bodyPr rtlCol="0" anchor="ctr"/>
+          <a:lstStyle/>
+          <a:p>
+            <a:pPr algn="ctr"/>
+          </a:p>
+        </p:txBody>
+      </p:sp>
+      <p:sp>
+        <p:nvSpPr>
+          <p:cNvPr id="21" name="TextBox 20"/>
+          <p:cNvSpPr txBox="1"/>
+          <p:nvPr/>
+        </p:nvSpPr>
+        <p:spPr>
+          <a:xfrm>
+            <a:off x="5074919" y="8092440"/>
+            <a:ext cx="1508759" cy="548640"/>
+          </a:xfrm>
+          <a:prstGeom prst="rect">
+            <a:avLst/>
+          </a:prstGeom>
+          <a:noFill/>
+        </p:spPr>
+        <p:txBody>
+          <a:bodyPr wrap="square" lIns="0" rIns="0" tIns="0" bIns="0" anchor="ctr">
+            <a:spAutoFit/>
+          </a:bodyPr>
+          <a:lstStyle/>
+          <a:p>
+            <a:pPr algn="ctr"/>
+            <a:r>
+              <a:rPr sz="1500" b="1" lang="en-US">
+                <a:solidFill>
+                  <a:srgbClr val="000000"/>
+                </a:solidFill>
+                <a:latin typeface="Helvetica World"/>
+              </a:rPr>
+              <a:t>WORK_OF_ART</a:t>
+            </a:r>
+          </a:p>
+          <a:p>
+            <a:pPr algn="ctr"/>
+            <a:r>
+              <a:rPr sz="1400" b="0" lang="en-US">
+                <a:solidFill>
+                  <a:srgbClr val="000000"/>
+                </a:solidFill>
+                <a:latin typeface="Helvetica World"/>
+              </a:rPr>
+              <a:t>titles of works</a:t>
+            </a:r>
+          </a:p>
+        </p:txBody>
+      </p:sp>
+      <p:sp>
+        <p:nvSpPr>
+          <p:cNvPr id="22" name="Entity GPE"/>
+          <p:cNvSpPr/>
+          <p:nvPr/>
+        </p:nvSpPr>
+        <p:spPr>
+          <a:xfrm>
+            <a:off x="6858000" y="8092440"/>
+            <a:ext cx="1691639" cy="548640"/>
+          </a:xfrm>
+          <a:prstGeom prst="rect">
+            <a:avLst/>
+          </a:prstGeom>
+          <a:solidFill>
+            <a:srgbClr val="FECA74"/>
+          </a:solidFill>
+          <a:ln>
+            <a:noFill/>
+          </a:ln>
+        </p:spPr>
+        <p:txBody>
+          <a:bodyPr rtlCol="0" anchor="ctr"/>
+          <a:lstStyle/>
+          <a:p>
+            <a:pPr algn="ctr"/>
+          </a:p>
+        </p:txBody>
+      </p:sp>
+      <p:sp>
+        <p:nvSpPr>
+          <p:cNvPr id="23" name="TextBox 22"/>
+          <p:cNvSpPr txBox="1"/>
+          <p:nvPr/>
+        </p:nvSpPr>
+        <p:spPr>
+          <a:xfrm>
+            <a:off x="6949440" y="8092440"/>
+            <a:ext cx="1508759" cy="548640"/>
+          </a:xfrm>
+          <a:prstGeom prst="rect">
+            <a:avLst/>
+          </a:prstGeom>
+          <a:noFill/>
+        </p:spPr>
+        <p:txBody>
+          <a:bodyPr wrap="square" lIns="0" rIns="0" tIns="0" bIns="0" anchor="ctr">
+            <a:spAutoFit/>
+          </a:bodyPr>
+          <a:lstStyle/>
+          <a:p>
+            <a:pPr algn="ctr"/>
+            <a:r>
+              <a:rPr sz="1500" b="1" lang="en-US">
+                <a:solidFill>
+                  <a:srgbClr val="000000"/>
+                </a:solidFill>
+                <a:latin typeface="Helvetica World"/>
+              </a:rPr>
+              <a:t>GPE</a:t>
+            </a:r>
+          </a:p>
+          <a:p>
+            <a:pPr algn="ctr"/>
+            <a:r>
+              <a:rPr sz="1400" b="0" lang="en-US">
+                <a:solidFill>
+                  <a:srgbClr val="000000"/>
+                </a:solidFill>
+                <a:latin typeface="Helvetica World"/>
+              </a:rPr>
+              <a:t>countries, cities</a:t>
+            </a:r>
+          </a:p>
+        </p:txBody>
+      </p:sp>
+      <p:sp>
+        <p:nvSpPr>
+          <p:cNvPr id="24" name="Card 2"/>
+          <p:cNvSpPr/>
+          <p:nvPr/>
+        </p:nvSpPr>
+        <p:spPr>
+          <a:xfrm>
+            <a:off x="9418320" y="2606040"/>
+            <a:ext cx="7955279" cy="6309360"/>
+          </a:xfrm>
+          <a:prstGeom prst="rect">
+            <a:avLst/>
+          </a:prstGeom>
+          <a:solidFill>
+            <a:srgbClr val="E1E3DE"/>
+          </a:solidFill>
+          <a:ln>
+            <a:noFill/>
+          </a:ln>
+        </p:spPr>
+        <p:txBody>
+          <a:bodyPr rtlCol="0" anchor="ctr"/>
+          <a:lstStyle/>
+          <a:p>
+            <a:pPr algn="ctr"/>
+          </a:p>
+        </p:txBody>
+      </p:sp>
+      <p:sp>
+        <p:nvSpPr>
+          <p:cNvPr id="25" name="Card 2 badge"/>
+          <p:cNvSpPr/>
+          <p:nvPr/>
+        </p:nvSpPr>
+        <p:spPr>
+          <a:xfrm>
+            <a:off x="9738360" y="2880360"/>
+            <a:ext cx="640080" cy="640080"/>
+          </a:xfrm>
+          <a:prstGeom prst="rect">
+            <a:avLst/>
+          </a:prstGeom>
+          <a:solidFill>
+            <a:srgbClr val="98C4EC"/>
+          </a:solidFill>
+          <a:ln>
+            <a:noFill/>
+          </a:ln>
+        </p:spPr>
+        <p:txBody>
+          <a:bodyPr rtlCol="0" anchor="ctr"/>
+          <a:lstStyle/>
+          <a:p>
+            <a:pPr algn="ctr"/>
+          </a:p>
+        </p:txBody>
+      </p:sp>
+      <p:sp>
+        <p:nvSpPr>
+          <p:cNvPr id="26" name="TextBox 25"/>
+          <p:cNvSpPr txBox="1"/>
+          <p:nvPr/>
+        </p:nvSpPr>
+        <p:spPr>
+          <a:xfrm>
+            <a:off x="9738360" y="2880360"/>
+            <a:ext cx="640080" cy="640080"/>
+          </a:xfrm>
+          <a:prstGeom prst="rect">
+            <a:avLst/>
+          </a:prstGeom>
+          <a:noFill/>
+        </p:spPr>
+        <p:txBody>
+          <a:bodyPr wrap="square" lIns="0" rIns="0" tIns="0" bIns="0" anchor="ctr">
+            <a:spAutoFit/>
+          </a:bodyPr>
+          <a:lstStyle/>
+          <a:p>
+            <a:pPr algn="ctr"/>
+            <a:r>
+              <a:rPr sz="2800" b="0" lang="en-US">
+                <a:solidFill>
+                  <a:srgbClr val="FFFFFF"/>
+                </a:solidFill>
+                <a:latin typeface="Helios Extended"/>
+              </a:rPr>
+              <a:t>02</a:t>
+            </a:r>
+          </a:p>
+        </p:txBody>
+      </p:sp>
+      <p:sp>
+        <p:nvSpPr>
+          <p:cNvPr id="27" name="TextBox 26"/>
+          <p:cNvSpPr txBox="1"/>
+          <p:nvPr/>
+        </p:nvSpPr>
+        <p:spPr>
+          <a:xfrm>
+            <a:off x="10561320" y="2880360"/>
+            <a:ext cx="6492239" cy="640080"/>
+          </a:xfrm>
+          <a:prstGeom prst="rect">
+            <a:avLst/>
+          </a:prstGeom>
+          <a:noFill/>
+        </p:spPr>
+        <p:txBody>
+          <a:bodyPr wrap="square" lIns="0" rIns="0" tIns="0" bIns="0" anchor="ctr">
+            <a:spAutoFit/>
+          </a:bodyPr>
+          <a:lstStyle/>
+          <a:p>
+            <a:pPr algn="l"/>
+            <a:r>
+              <a:rPr sz="2400" b="1" lang="en-US">
+                <a:solidFill>
+                  <a:srgbClr val="000000"/>
+                </a:solidFill>
+                <a:latin typeface="Helvetica World"/>
+              </a:rPr>
+              <a:t>Review sentiment with TF-IDF + classic ML</a:t>
+            </a:r>
+          </a:p>
+        </p:txBody>
+      </p:sp>
+      <p:sp>
+        <p:nvSpPr>
+          <p:cNvPr id="28" name="TextBox 27"/>
+          <p:cNvSpPr txBox="1"/>
+          <p:nvPr/>
+        </p:nvSpPr>
+        <p:spPr>
+          <a:xfrm>
+            <a:off x="9738360" y="3703320"/>
+            <a:ext cx="7315199" cy="1463040"/>
+          </a:xfrm>
+          <a:prstGeom prst="rect">
+            <a:avLst/>
+          </a:prstGeom>
+          <a:noFill/>
+        </p:spPr>
+        <p:txBody>
+          <a:bodyPr wrap="square" lIns="0" rIns="0" tIns="0" bIns="0" anchor="t">
+            <a:spAutoFit/>
+          </a:bodyPr>
+          <a:lstStyle/>
+          <a:p>
+            <a:pPr algn="l" marL="320040" indent="-320040">
+              <a:spcAft>
+                <a:spcPts val="800"/>
+              </a:spcAft>
+              <a:buFont typeface="Arial"/>
+              <a:buChar char="•"/>
+            </a:pPr>
+            <a:r>
+              <a:rPr sz="2000" b="0" lang="en-US">
+                <a:solidFill>
+                  <a:srgbClr val="000000"/>
+                </a:solidFill>
+                <a:latin typeface="Helvetica World"/>
+              </a:rPr>
+              <a:t>Cleaned long reviews (stop-word removal, stemming) and turned them into TF-IDF vectors</a:t>
+            </a:r>
+          </a:p>
+          <a:p>
+            <a:pPr algn="l" marL="320040" indent="-320040">
+              <a:spcAft>
+                <a:spcPts val="800"/>
+              </a:spcAft>
+              <a:buFont typeface="Arial"/>
+              <a:buChar char="•"/>
+            </a:pPr>
+            <a:r>
+              <a:rPr sz="2000" b="0" lang="en-US">
+                <a:solidFill>
+                  <a:srgbClr val="000000"/>
+                </a:solidFill>
+                <a:latin typeface="Helvetica World"/>
+              </a:rPr>
+              <a:t>Compared three supervised classifiers on the same vectors; word cloud of the positive reviews</a:t>
+            </a:r>
+          </a:p>
+        </p:txBody>
+      </p:sp>
+      <p:sp>
+        <p:nvSpPr>
+          <p:cNvPr id="29" name="Card 2 code"/>
+          <p:cNvSpPr/>
+          <p:nvPr/>
+        </p:nvSpPr>
+        <p:spPr>
+          <a:xfrm>
+            <a:off x="9738360" y="5257800"/>
+            <a:ext cx="7315199" cy="777240"/>
+          </a:xfrm>
+          <a:prstGeom prst="rect">
+            <a:avLst/>
+          </a:prstGeom>
+          <a:solidFill>
+            <a:srgbClr val="FFFFFF"/>
+          </a:solidFill>
+          <a:ln>
+            <a:noFill/>
+          </a:ln>
+        </p:spPr>
+        <p:txBody>
+          <a:bodyPr rtlCol="0" anchor="ctr"/>
+          <a:lstStyle/>
+          <a:p>
+            <a:pPr algn="ctr"/>
+          </a:p>
+        </p:txBody>
+      </p:sp>
+      <p:sp>
+        <p:nvSpPr>
+          <p:cNvPr id="30" name="TextBox 29"/>
+          <p:cNvSpPr txBox="1"/>
+          <p:nvPr/>
+        </p:nvSpPr>
+        <p:spPr>
+          <a:xfrm>
+            <a:off x="9921240" y="5257800"/>
+            <a:ext cx="6949439" cy="777240"/>
+          </a:xfrm>
+          <a:prstGeom prst="rect">
+            <a:avLst/>
+          </a:prstGeom>
+          <a:noFill/>
+        </p:spPr>
+        <p:txBody>
+          <a:bodyPr wrap="square" lIns="0" rIns="0" tIns="0" bIns="0" anchor="ctr">
+            <a:spAutoFit/>
+          </a:bodyPr>
+          <a:lstStyle/>
+          <a:p>
+            <a:pPr algn="l"/>
+            <a:r>
+              <a:rPr sz="1600" b="0" lang="en-US">
+                <a:solidFill>
+                  <a:srgbClr val="000000"/>
+                </a:solidFill>
+                <a:latin typeface="Courier New"/>
+              </a:rPr>
+              <a:t>WC = WordCloud(width=1000, height=500,</a:t>
+            </a:r>
+          </a:p>
+          <a:p>
+            <a:pPr algn="l"/>
+            <a:r>
+              <a:rPr sz="1600" b="0" lang="en-US">
+                <a:solidFill>
+                  <a:srgbClr val="000000"/>
+                </a:solidFill>
+                <a:latin typeface="Courier New"/>
+              </a:rPr>
+              <a:t>               max_words=500, min_font_size=5)</a:t>
+            </a:r>
+          </a:p>
+        </p:txBody>
+      </p:sp>
+      <p:pic>
+        <p:nvPicPr>
+          <p:cNvPr id="31" name="Word cloud" descr="wordcloud.png"/>
+          <p:cNvPicPr>
+            <a:picLocks noChangeAspect="1"/>
+          </p:cNvPicPr>
+          <p:nvPr/>
+        </p:nvPicPr>
+        <p:blipFill>
+          <a:blip r:embed="rId3"/>
+          <a:stretch>
+            <a:fillRect/>
+          </a:stretch>
+        </p:blipFill>
+        <p:spPr>
+          <a:xfrm>
+            <a:off x="9738360" y="6217920"/>
+            <a:ext cx="3383280" cy="1694666"/>
+          </a:xfrm>
+          <a:prstGeom prst="rect">
+            <a:avLst/>
+          </a:prstGeom>
+        </p:spPr>
+      </p:pic>
+      <p:sp>
+        <p:nvSpPr>
+          <p:cNvPr id="32" name="Word cloud caption"/>
+          <p:cNvSpPr txBox="1"/>
+          <p:nvPr/>
+        </p:nvSpPr>
+        <p:spPr>
+          <a:xfrm>
+            <a:off x="13395960" y="6217920"/>
+            <a:ext cx="3657599" cy="1694666"/>
+          </a:xfrm>
+          <a:prstGeom prst="rect">
+            <a:avLst/>
+          </a:prstGeom>
+          <a:noFill/>
+        </p:spPr>
+        <p:txBody>
+          <a:bodyPr wrap="square" lIns="0" rIns="0" tIns="0" bIns="0" anchor="ctr">
+            <a:spAutoFit/>
+          </a:bodyPr>
+          <a:lstStyle/>
+          <a:p>
+            <a:pPr algn="l"/>
+            <a:r>
+              <a:rPr sz="1600" b="0" lang="en-US">
+                <a:solidFill>
+                  <a:srgbClr val="555555"/>
+                </a:solidFill>
+                <a:latin typeface="Helvetica World"/>
+              </a:rPr>
+              <a:t>Word cloud of the positive reviews after stemming: 'well', 'littl', 'product', 'master' and 'realism' dominate.</a:t>
+            </a:r>
+          </a:p>
+        </p:txBody>
+      </p:sp>
+      <p:sp>
+        <p:nvSpPr>
+          <p:cNvPr id="33" name="Classifier 1"/>
+          <p:cNvSpPr/>
+          <p:nvPr/>
+        </p:nvSpPr>
+        <p:spPr>
+          <a:xfrm>
+            <a:off x="9738360" y="8092440"/>
+            <a:ext cx="2316479" cy="548640"/>
+          </a:xfrm>
+          <a:prstGeom prst="rect">
+            <a:avLst/>
+          </a:prstGeom>
+          <a:solidFill>
+            <a:srgbClr val="FFFFFF"/>
+          </a:solidFill>
+          <a:ln>
+            <a:noFill/>
+          </a:ln>
+        </p:spPr>
+        <p:txBody>
+          <a:bodyPr rtlCol="0" anchor="ctr"/>
+          <a:lstStyle/>
+          <a:p>
+            <a:pPr algn="ctr"/>
+          </a:p>
+        </p:txBody>
+      </p:sp>
+      <p:sp>
+        <p:nvSpPr>
+          <p:cNvPr id="34" name="TextBox 33"/>
+          <p:cNvSpPr txBox="1"/>
+          <p:nvPr/>
+        </p:nvSpPr>
+        <p:spPr>
+          <a:xfrm>
+            <a:off x="9829800" y="8092440"/>
+            <a:ext cx="2133599" cy="548640"/>
+          </a:xfrm>
+          <a:prstGeom prst="rect">
+            <a:avLst/>
+          </a:prstGeom>
+          <a:noFill/>
+        </p:spPr>
+        <p:txBody>
+          <a:bodyPr wrap="square" lIns="0" rIns="0" tIns="0" bIns="0" anchor="ctr">
+            <a:spAutoFit/>
+          </a:bodyPr>
+          <a:lstStyle/>
+          <a:p>
+            <a:pPr algn="ctr"/>
+            <a:r>
+              <a:rPr sz="1600" b="1" lang="en-US">
+                <a:solidFill>
+                  <a:srgbClr val="000000"/>
+                </a:solidFill>
+                <a:latin typeface="Helvetica World"/>
+              </a:rPr>
+              <a:t>Logistic Regression</a:t>
+            </a:r>
+          </a:p>
+        </p:txBody>
+      </p:sp>
+      <p:sp>
+        <p:nvSpPr>
+          <p:cNvPr id="35" name="Classifier 2"/>
+          <p:cNvSpPr/>
+          <p:nvPr/>
+        </p:nvSpPr>
+        <p:spPr>
+          <a:xfrm>
+            <a:off x="12237720" y="8092440"/>
+            <a:ext cx="2316479" cy="548640"/>
+          </a:xfrm>
+          <a:prstGeom prst="rect">
+            <a:avLst/>
+          </a:prstGeom>
+          <a:solidFill>
+            <a:srgbClr val="FFFFFF"/>
+          </a:solidFill>
+          <a:ln>
+            <a:noFill/>
+          </a:ln>
+        </p:spPr>
+        <p:txBody>
+          <a:bodyPr rtlCol="0" anchor="ctr"/>
+          <a:lstStyle/>
+          <a:p>
+            <a:pPr algn="ctr"/>
+          </a:p>
+        </p:txBody>
+      </p:sp>
+      <p:sp>
+        <p:nvSpPr>
+          <p:cNvPr id="36" name="TextBox 35"/>
+          <p:cNvSpPr txBox="1"/>
+          <p:nvPr/>
+        </p:nvSpPr>
+        <p:spPr>
+          <a:xfrm>
+            <a:off x="12329160" y="8092440"/>
+            <a:ext cx="2133599" cy="548640"/>
+          </a:xfrm>
+          <a:prstGeom prst="rect">
+            <a:avLst/>
+          </a:prstGeom>
+          <a:noFill/>
+        </p:spPr>
+        <p:txBody>
+          <a:bodyPr wrap="square" lIns="0" rIns="0" tIns="0" bIns="0" anchor="ctr">
+            <a:spAutoFit/>
+          </a:bodyPr>
+          <a:lstStyle/>
+          <a:p>
+            <a:pPr algn="ctr"/>
+            <a:r>
+              <a:rPr sz="1600" b="1" lang="en-US">
+                <a:solidFill>
+                  <a:srgbClr val="000000"/>
+                </a:solidFill>
+                <a:latin typeface="Helvetica World"/>
+              </a:rPr>
+              <a:t>Support Vector Machine</a:t>
+            </a:r>
+          </a:p>
+        </p:txBody>
+      </p:sp>
+      <p:sp>
+        <p:nvSpPr>
+          <p:cNvPr id="37" name="Classifier 3"/>
+          <p:cNvSpPr/>
+          <p:nvPr/>
+        </p:nvSpPr>
+        <p:spPr>
+          <a:xfrm>
+            <a:off x="14737080" y="8092440"/>
+            <a:ext cx="2316479" cy="548640"/>
+          </a:xfrm>
+          <a:prstGeom prst="rect">
+            <a:avLst/>
+          </a:prstGeom>
+          <a:solidFill>
+            <a:srgbClr val="FFFFFF"/>
+          </a:solidFill>
+          <a:ln>
+            <a:noFill/>
+          </a:ln>
+        </p:spPr>
+        <p:txBody>
+          <a:bodyPr rtlCol="0" anchor="ctr"/>
+          <a:lstStyle/>
+          <a:p>
+            <a:pPr algn="ctr"/>
+          </a:p>
+        </p:txBody>
+      </p:sp>
+      <p:sp>
+        <p:nvSpPr>
+          <p:cNvPr id="38" name="TextBox 37"/>
+          <p:cNvSpPr txBox="1"/>
+          <p:nvPr/>
+        </p:nvSpPr>
+        <p:spPr>
+          <a:xfrm>
+            <a:off x="14828520" y="8092440"/>
+            <a:ext cx="2133599" cy="548640"/>
+          </a:xfrm>
+          <a:prstGeom prst="rect">
+            <a:avLst/>
+          </a:prstGeom>
+          <a:noFill/>
+        </p:spPr>
+        <p:txBody>
+          <a:bodyPr wrap="square" lIns="0" rIns="0" tIns="0" bIns="0" anchor="ctr">
+            <a:spAutoFit/>
+          </a:bodyPr>
+          <a:lstStyle/>
+          <a:p>
+            <a:pPr algn="ctr"/>
+            <a:r>
+              <a:rPr sz="1600" b="1" lang="en-US">
+                <a:solidFill>
+                  <a:srgbClr val="000000"/>
+                </a:solidFill>
+                <a:latin typeface="Helvetica World"/>
+              </a:rPr>
+              <a:t>Multinomial Naive Bayes</a:t>
+            </a:r>
+          </a:p>
+        </p:txBody>
+      </p:sp>
+    </p:spTree>
+  </p:cSld>
+  <p:clrMapOvr>
+    <a:masterClrMapping/>
+  </p:clrMapOvr>
+</p:sld>
+</file>
+
 <file path=ppt/theme/theme1.xml><?xml version="1.0" encoding="utf-8"?>
 <a:theme xmlns:a="http://schemas.openxmlformats.org/drawingml/2006/main" name="Office Theme">
   <a:themeElements>

</xml_diff>

<commit_message>
Translate the results slide to English
Co-Authored-By: Claude Fable 5.1 <noreply@anthropic.com>
Claude-Session: https://claude.ai/code/session_013C7PUHkdKFR5RJx432vMai
</commit_message>
<xml_diff>
--- a/slides/cars_classification_slides.pptx
+++ b/slides/cars_classification_slides.pptx
@@ -7733,13 +7733,13 @@
           <a:p>
             <a:pPr algn="l"/>
             <a:r>
-              <a:rPr sz="6000" b="0" lang="vi-VN" spc="-300">
+              <a:rPr sz="6000" b="0" lang="en-US" spc="-300">
                 <a:solidFill>
                   <a:srgbClr val="000000"/>
                 </a:solidFill>
                 <a:latin typeface="Helios Extended"/>
               </a:rPr>
-              <a:t>Kết quả thực hiện</a:t>
+              <a:t>Results</a:t>
             </a:r>
           </a:p>
         </p:txBody>
@@ -7768,13 +7768,13 @@
           <a:p>
             <a:pPr algn="l"/>
             <a:r>
-              <a:rPr sz="2400" b="0" lang="vi-VN">
+              <a:rPr sz="2400" b="0" lang="en-US">
                 <a:solidFill>
                   <a:srgbClr val="555555"/>
                 </a:solidFill>
                 <a:latin typeface="Helvetica World"/>
               </a:rPr>
-              <a:t>Huấn luyện 50 epoch, chọn checkpoint có validation accuracy cao nhất để kiểm thử trên 616 ảnh test</a:t>
+              <a:t>Trained for 50 epochs; the checkpoint with the best validation accuracy was tested on 616 test images</a:t>
             </a:r>
           </a:p>
         </p:txBody>
@@ -7902,13 +7902,13 @@
           <a:p>
             <a:pPr algn="l"/>
             <a:r>
-              <a:rPr sz="2400" b="1" lang="vi-VN">
+              <a:rPr sz="2400" b="1" lang="en-US">
                 <a:solidFill>
                   <a:srgbClr val="000000"/>
                 </a:solidFill>
                 <a:latin typeface="Helvetica World"/>
               </a:rPr>
-              <a:t>Validation accuracy qua 50 epoch</a:t>
+              <a:t>Validation accuracy over 50 epochs</a:t>
             </a:r>
           </a:p>
         </p:txBody>
@@ -7984,13 +7984,13 @@
           <a:p>
             <a:pPr algn="l"/>
             <a:r>
-              <a:rPr sz="1500" b="0" lang="vi-VN" spc="150">
+              <a:rPr sz="1500" b="0" lang="en-US" spc="150">
                 <a:solidFill>
                   <a:srgbClr val="555555"/>
                 </a:solidFill>
                 <a:latin typeface="Helvetica World"/>
               </a:rPr>
-              <a:t>VALIDATION CAO NHẤT</a:t>
+              <a:t>BEST VALIDATION ACCURACY</a:t>
             </a:r>
           </a:p>
         </p:txBody>
@@ -8019,7 +8019,7 @@
           <a:p>
             <a:pPr algn="l"/>
             <a:r>
-              <a:rPr sz="4000" b="0" lang="vi-VN" spc="-100">
+              <a:rPr sz="4000" b="0" lang="en-US" spc="-100">
                 <a:solidFill>
                   <a:srgbClr val="000000"/>
                 </a:solidFill>
@@ -8054,13 +8054,13 @@
           <a:p>
             <a:pPr algn="l"/>
             <a:r>
-              <a:rPr sz="1800" b="0" lang="vi-VN">
+              <a:rPr sz="1800" b="0" lang="en-US">
                 <a:solidFill>
                   <a:srgbClr val="555555"/>
                 </a:solidFill>
                 <a:latin typeface="Helvetica World"/>
               </a:rPr>
-              <a:t>tại epoch 48 / 50</a:t>
+              <a:t>at epoch 48 of 50</a:t>
             </a:r>
           </a:p>
         </p:txBody>
@@ -8118,13 +8118,13 @@
           <a:p>
             <a:pPr algn="l"/>
             <a:r>
-              <a:rPr sz="1500" b="0" lang="vi-VN" spc="150">
+              <a:rPr sz="1500" b="0" lang="en-US" spc="150">
                 <a:solidFill>
                   <a:srgbClr val="555555"/>
                 </a:solidFill>
                 <a:latin typeface="Helvetica World"/>
               </a:rPr>
-              <a:t>ĐỘ CHÍNH XÁC TEST</a:t>
+              <a:t>TEST ACCURACY</a:t>
             </a:r>
           </a:p>
         </p:txBody>
@@ -8153,7 +8153,7 @@
           <a:p>
             <a:pPr algn="l"/>
             <a:r>
-              <a:rPr sz="4000" b="0" lang="vi-VN" spc="-100">
+              <a:rPr sz="4000" b="0" lang="en-US" spc="-100">
                 <a:solidFill>
                   <a:srgbClr val="000000"/>
                 </a:solidFill>
@@ -8188,13 +8188,13 @@
           <a:p>
             <a:pPr algn="l"/>
             <a:r>
-              <a:rPr sz="1800" b="0" lang="vi-VN">
+              <a:rPr sz="1800" b="0" lang="en-US">
                 <a:solidFill>
                   <a:srgbClr val="555555"/>
                 </a:solidFill>
                 <a:latin typeface="Helvetica World"/>
               </a:rPr>
-              <a:t>303 / 616 ảnh test đúng</a:t>
+              <a:t>303 of 616 test images correct</a:t>
             </a:r>
           </a:p>
         </p:txBody>
@@ -8223,13 +8223,13 @@
           <a:p>
             <a:pPr algn="l"/>
             <a:r>
-              <a:rPr sz="2400" b="1" lang="vi-VN">
+              <a:rPr sz="2400" b="1" lang="en-US">
                 <a:solidFill>
                   <a:srgbClr val="000000"/>
                 </a:solidFill>
                 <a:latin typeface="Helvetica World"/>
               </a:rPr>
-              <a:t>Confusion matrix trên tập test (epoch tốt nhất)</a:t>
+              <a:t>Confusion matrix on the test set (best epoch)</a:t>
             </a:r>
           </a:p>
         </p:txBody>
@@ -8253,7 +8253,7 @@
                 <a:tableStyleId>{2D5ABB26-0587-4C30-8999-92F81FD0307C}</a:tableStyleId>
               </a:tblPr>
               <a:tblGrid>
-                <a:gridCol w="1188720"/>
+                <a:gridCol w="1371600"/>
                 <a:gridCol w="731520"/>
                 <a:gridCol w="731520"/>
                 <a:gridCol w="731520"/>
@@ -8261,7 +8261,7 @@
                 <a:gridCol w="731520"/>
                 <a:gridCol w="731520"/>
                 <a:gridCol w="731520"/>
-                <a:gridCol w="1737360"/>
+                <a:gridCol w="1554480"/>
               </a:tblGrid>
               <a:tr h="566928">
                 <a:tc>
@@ -8271,25 +8271,25 @@
                     <a:p>
                       <a:pPr algn="ctr"/>
                       <a:r>
-                        <a:rPr sz="1400" b="1" lang="vi-VN">
+                        <a:rPr sz="1400" b="1" lang="en-US">
                           <a:solidFill>
                             <a:srgbClr val="FFFFFF"/>
                           </a:solidFill>
                           <a:latin typeface="Helvetica World"/>
                         </a:rPr>
-                        <a:t>Thực tế ↓</a:t>
-                      </a:r>
-                    </a:p>
-                    <a:p>
-                      <a:pPr algn="ctr"/>
-                      <a:r>
-                        <a:rPr sz="1400" b="1" lang="vi-VN">
+                        <a:t>Actual ↓</a:t>
+                      </a:r>
+                    </a:p>
+                    <a:p>
+                      <a:pPr algn="ctr"/>
+                      <a:r>
+                        <a:rPr sz="1400" b="1" lang="en-US">
                           <a:solidFill>
                             <a:srgbClr val="FFFFFF"/>
                           </a:solidFill>
                           <a:latin typeface="Helvetica World"/>
                         </a:rPr>
-                        <a:t>Dự đoán →</a:t>
+                        <a:t>Predicted →</a:t>
                       </a:r>
                     </a:p>
                   </a:txBody>
@@ -8659,13 +8659,13 @@
                     <a:p>
                       <a:pPr algn="ctr"/>
                       <a:r>
-                        <a:rPr sz="2000" b="1" lang="vi-VN">
+                        <a:rPr sz="2000" b="1" lang="en-US">
                           <a:solidFill>
                             <a:srgbClr val="FFFFFF"/>
                           </a:solidFill>
                           <a:latin typeface="Helvetica World"/>
                         </a:rPr>
-                        <a:t>Đúng (%)</a:t>
+                        <a:t>Accuracy</a:t>
                       </a:r>
                     </a:p>
                   </a:txBody>
@@ -8708,13 +8708,13 @@
                     <a:p>
                       <a:pPr algn="ctr"/>
                       <a:r>
-                        <a:rPr sz="2000" b="1" lang="vi-VN">
+                        <a:rPr sz="2000" b="1" lang="en-US">
                           <a:solidFill>
                             <a:srgbClr val="000000"/>
                           </a:solidFill>
                           <a:latin typeface="Helvetica World"/>
                         </a:rPr>
-                        <a:t>Lớp 0</a:t>
+                        <a:t>Class 0</a:t>
                       </a:r>
                     </a:p>
                   </a:txBody>
@@ -9133,13 +9133,13 @@
                     <a:p>
                       <a:pPr algn="ctr"/>
                       <a:r>
-                        <a:rPr sz="2000" b="1" lang="vi-VN">
+                        <a:rPr sz="2000" b="1" lang="en-US">
                           <a:solidFill>
                             <a:srgbClr val="000000"/>
                           </a:solidFill>
                           <a:latin typeface="Helvetica World"/>
                         </a:rPr>
-                        <a:t>Lớp 1</a:t>
+                        <a:t>Class 1</a:t>
                       </a:r>
                     </a:p>
                   </a:txBody>
@@ -9558,13 +9558,13 @@
                     <a:p>
                       <a:pPr algn="ctr"/>
                       <a:r>
-                        <a:rPr sz="2000" b="1" lang="vi-VN">
+                        <a:rPr sz="2000" b="1" lang="en-US">
                           <a:solidFill>
                             <a:srgbClr val="000000"/>
                           </a:solidFill>
                           <a:latin typeface="Helvetica World"/>
                         </a:rPr>
-                        <a:t>Lớp 2</a:t>
+                        <a:t>Class 2</a:t>
                       </a:r>
                     </a:p>
                   </a:txBody>
@@ -9983,13 +9983,13 @@
                     <a:p>
                       <a:pPr algn="ctr"/>
                       <a:r>
-                        <a:rPr sz="2000" b="1" lang="vi-VN">
+                        <a:rPr sz="2000" b="1" lang="en-US">
                           <a:solidFill>
                             <a:srgbClr val="000000"/>
                           </a:solidFill>
                           <a:latin typeface="Helvetica World"/>
                         </a:rPr>
-                        <a:t>Lớp 3</a:t>
+                        <a:t>Class 3</a:t>
                       </a:r>
                     </a:p>
                   </a:txBody>
@@ -10408,13 +10408,13 @@
                     <a:p>
                       <a:pPr algn="ctr"/>
                       <a:r>
-                        <a:rPr sz="2000" b="1" lang="vi-VN">
+                        <a:rPr sz="2000" b="1" lang="en-US">
                           <a:solidFill>
                             <a:srgbClr val="000000"/>
                           </a:solidFill>
                           <a:latin typeface="Helvetica World"/>
                         </a:rPr>
-                        <a:t>Lớp 4</a:t>
+                        <a:t>Class 4</a:t>
                       </a:r>
                     </a:p>
                   </a:txBody>
@@ -10833,13 +10833,13 @@
                     <a:p>
                       <a:pPr algn="ctr"/>
                       <a:r>
-                        <a:rPr sz="2000" b="1" lang="vi-VN">
+                        <a:rPr sz="2000" b="1" lang="en-US">
                           <a:solidFill>
                             <a:srgbClr val="000000"/>
                           </a:solidFill>
                           <a:latin typeface="Helvetica World"/>
                         </a:rPr>
-                        <a:t>Lớp 5</a:t>
+                        <a:t>Class 5</a:t>
                       </a:r>
                     </a:p>
                   </a:txBody>
@@ -11258,13 +11258,13 @@
                     <a:p>
                       <a:pPr algn="ctr"/>
                       <a:r>
-                        <a:rPr sz="2000" b="1" lang="vi-VN">
+                        <a:rPr sz="2000" b="1" lang="en-US">
                           <a:solidFill>
                             <a:srgbClr val="000000"/>
                           </a:solidFill>
                           <a:latin typeface="Helvetica World"/>
                         </a:rPr>
-                        <a:t>Lớp 6</a:t>
+                        <a:t>Class 6</a:t>
                       </a:r>
                     </a:p>
                   </a:txBody>
@@ -11738,13 +11738,13 @@
               <a:buChar char="•"/>
             </a:pPr>
             <a:r>
-              <a:rPr sz="1900" b="0" lang="vi-VN">
+              <a:rPr sz="1900" b="0" lang="en-US">
                 <a:solidFill>
                   <a:srgbClr val="000000"/>
                 </a:solidFill>
                 <a:latin typeface="Helvetica World"/>
               </a:rPr>
-              <a:t>Lớp 4 và lớp 5 nhận dạng tốt nhất (68% và 67%); lớp 3 kém nhất (28%), hay bị nhầm sang lớp 0.</a:t>
+              <a:t>Classes 4 and 5 are recognised best (68% and 67%); class 3 is weakest (28%) and is often confused with class 0.</a:t>
             </a:r>
           </a:p>
           <a:p>
@@ -11753,13 +11753,13 @@
               <a:buChar char="•"/>
             </a:pPr>
             <a:r>
-              <a:rPr sz="1900" b="0" lang="vi-VN">
+              <a:rPr sz="1900" b="0" lang="en-US">
                 <a:solidFill>
                   <a:srgbClr val="000000"/>
                 </a:solidFill>
                 <a:latin typeface="Helvetica World"/>
               </a:rPr>
-              <a:t>Validation ≈ 90% nhưng test chỉ 49.2% → mô hình overfit; hướng cải thiện: data augmentation, dropout, mạng sâu hơn.</a:t>
+              <a:t>Validation ≈ 90% but test only 49.2% → the model overfits; next steps: data augmentation, dropout, a deeper network.</a:t>
             </a:r>
           </a:p>
         </p:txBody>

</xml_diff>